<commit_message>
fix: emit true-angle gradients for PPTX backgrounds, overlays and text
The web draws slide backgrounds, overlays and text-color gradients with CSS
linear-gradient, where the angle is a true angle on the box. PPTX wrote
every linear gradient with a:lin scaled="1", which stretches the angle with
the box's aspect ratio, so a 210deg band tilted about 30 degrees on the web
and about 18 degrees in PPTX on a 16:9 slide. Those fills now use
scaled="0"; shape fills and borders keep scaled="1" to match the web's SVG
objectBoundingBox gradients.
</commit_message>
<xml_diff>
--- a/examples/showcase/decks/balpyo-intro/introducing-balpyo.pptx
+++ b/examples/showcase/decks/balpyo-intro/introducing-balpyo.pptx
@@ -1151,7 +1151,7 @@
                       <a:schemeClr val="accent6"/>
                     </a:gs>
                   </a:gsLst>
-                  <a:lin ang="0" scaled="1"/>
+                  <a:lin ang="0" scaled="0"/>
                 </a:gradFill>
                 <a:latin typeface="+mj-lt"/>
                 <a:ea typeface="+mj-ea"/>
@@ -6557,7 +6557,7 @@
                       <a:schemeClr val="accent6"/>
                     </a:gs>
                   </a:gsLst>
-                  <a:lin ang="0" scaled="1"/>
+                  <a:lin ang="0" scaled="0"/>
                 </a:gradFill>
                 <a:latin typeface="+mj-lt"/>
                 <a:ea typeface="+mj-ea"/>

</xml_diff>

<commit_message>
doc: regenerate showcase pptx with the deck language
</commit_message>
<xml_diff>
--- a/examples/showcase/decks/balpyo-intro/introducing-balpyo.pptx
+++ b/examples/showcase/decks/balpyo-intro/introducing-balpyo.pptx
@@ -23,6 +23,11 @@
   </p:sldIdLst>
   <p:sldSz cx="12192000" cy="6858000"/>
   <p:notesSz cx="6858000" cy="9144000"/>
+  <p:defaultTextStyle>
+    <a:defPPr>
+      <a:defRPr lang="en-US"/>
+    </a:defPPr>
+  </p:defaultTextStyle>
 </p:presentation>
 </file>
 
@@ -99,6 +104,9 @@
   </p:cSld>
   <p:clrMap bg1="lt1" tx1="dk1" bg2="lt2" tx2="dk2" accent1="accent1" accent2="accent2" accent3="accent3" accent4="accent4" accent5="accent5" accent6="accent6" hlink="hlink" folHlink="folHlink"/>
   <p:notesStyle>
+    <a:defPPr>
+      <a:defRPr lang="en-US"/>
+    </a:defPPr>
     <a:lvl1pPr>
       <a:defRPr sz="1200"/>
     </a:lvl1pPr>
@@ -1032,16 +1040,26 @@
   </p:sldLayoutIdLst>
   <p:txStyles>
     <p:titleStyle>
+      <a:defPPr>
+        <a:defRPr lang="en-US"/>
+      </a:defPPr>
       <a:lvl1pPr algn="l">
         <a:defRPr sz="4400"/>
       </a:lvl1pPr>
     </p:titleStyle>
     <p:bodyStyle>
+      <a:defPPr>
+        <a:defRPr lang="en-US"/>
+      </a:defPPr>
       <a:lvl1pPr>
         <a:defRPr sz="2400"/>
       </a:lvl1pPr>
     </p:bodyStyle>
-    <p:otherStyle/>
+    <p:otherStyle>
+      <a:defPPr>
+        <a:defRPr lang="en-US"/>
+      </a:defPPr>
+    </p:otherStyle>
   </p:txStyles>
 </p:sldMaster>
 </file>

</xml_diff>

<commit_message>
doc: regenerate the showcase with the deck language in PPTX
</commit_message>
<xml_diff>
--- a/examples/showcase/decks/balpyo-intro/introducing-balpyo.pptx
+++ b/examples/showcase/decks/balpyo-intro/introducing-balpyo.pptx
@@ -23,6 +23,11 @@
   </p:sldIdLst>
   <p:sldSz cx="12192000" cy="6858000"/>
   <p:notesSz cx="6858000" cy="9144000"/>
+  <p:defaultTextStyle>
+    <a:defPPr>
+      <a:defRPr lang="en-US"/>
+    </a:defPPr>
+  </p:defaultTextStyle>
 </p:presentation>
 </file>
 
@@ -99,6 +104,9 @@
   </p:cSld>
   <p:clrMap bg1="lt1" tx1="dk1" bg2="lt2" tx2="dk2" accent1="accent1" accent2="accent2" accent3="accent3" accent4="accent4" accent5="accent5" accent6="accent6" hlink="hlink" folHlink="folHlink"/>
   <p:notesStyle>
+    <a:defPPr>
+      <a:defRPr lang="en-US"/>
+    </a:defPPr>
     <a:lvl1pPr>
       <a:defRPr sz="1200"/>
     </a:lvl1pPr>
@@ -1032,16 +1040,26 @@
   </p:sldLayoutIdLst>
   <p:txStyles>
     <p:titleStyle>
+      <a:defPPr>
+        <a:defRPr lang="en-US"/>
+      </a:defPPr>
       <a:lvl1pPr algn="l">
         <a:defRPr sz="4400"/>
       </a:lvl1pPr>
     </p:titleStyle>
     <p:bodyStyle>
+      <a:defPPr>
+        <a:defRPr lang="en-US"/>
+      </a:defPPr>
       <a:lvl1pPr>
         <a:defRPr sz="2400"/>
       </a:lvl1pPr>
     </p:bodyStyle>
-    <p:otherStyle/>
+    <p:otherStyle>
+      <a:defPPr>
+        <a:defRPr lang="en-US"/>
+      </a:defPPr>
+    </p:otherStyle>
   </p:txStyles>
 </p:sldMaster>
 </file>

</xml_diff>